<commit_message>
feat: enhance mobile compatibility and responsiveness across map, dashboard, and navigation
</commit_message>
<xml_diff>
--- a/SubsiGuard_SIH2026_Corrected.pptx
+++ b/SubsiGuard_SIH2026_Corrected.pptx
@@ -5068,8 +5068,8 @@
         </p:nvSpPr>
         <p:spPr>
           <a:xfrm>
-            <a:off x="382268" y="4849507"/>
-            <a:ext cx="9001125" cy="514350"/>
+            <a:off x="419099" y="5408368"/>
+            <a:ext cx="12406999" cy="714374"/>
           </a:xfrm>
           <a:prstGeom prst="rect">
             <a:avLst/>
@@ -5085,6 +5085,60 @@
           </a:bodyPr>
           <a:lstStyle/>
           <a:p>
+            <a:pPr marL="0" marR="0" lvl="0" indent="0" algn="l" defTabSz="914400" rtl="0" eaLnBrk="1" fontAlgn="auto" latinLnBrk="0" hangingPunct="1">
+              <a:lnSpc>
+                <a:spcPct val="100000"/>
+              </a:lnSpc>
+              <a:spcBef>
+                <a:spcPts val="0"/>
+              </a:spcBef>
+              <a:spcAft>
+                <a:spcPts val="0"/>
+              </a:spcAft>
+              <a:buClrTx/>
+              <a:buSzTx/>
+              <a:buFontTx/>
+              <a:buNone/>
+              <a:tabLst/>
+              <a:defRPr sz="2025" b="0">
+                <a:solidFill>
+                  <a:srgbClr val="193247"/>
+                </a:solidFill>
+                <a:latin typeface="Arial"/>
+                <a:ea typeface="Arial"/>
+                <a:cs typeface="Arial"/>
+              </a:defRPr>
+            </a:pPr>
+            <a:r>
+              <a:rPr lang="en-US" sz="3150" b="1" dirty="0">
+                <a:solidFill>
+                  <a:srgbClr val="214E80"/>
+                </a:solidFill>
+                <a:latin typeface="Arial"/>
+                <a:ea typeface="Arial"/>
+                <a:cs typeface="Arial"/>
+              </a:rPr>
+              <a:t>Problem Statement Title:-   </a:t>
+            </a:r>
+            <a:r>
+              <a:rPr kumimoji="0" lang="en-US" sz="3038" b="0" i="0" u="none" strike="noStrike" kern="1200" cap="none" spc="0" normalizeH="0" baseline="0" noProof="0" dirty="0">
+                <a:ln>
+                  <a:noFill/>
+                </a:ln>
+                <a:solidFill>
+                  <a:srgbClr val="193247"/>
+                </a:solidFill>
+                <a:effectLst/>
+                <a:uLnTx/>
+                <a:uFillTx/>
+                <a:latin typeface="Arial"/>
+                <a:ea typeface="Arial"/>
+                <a:cs typeface="Arial"/>
+              </a:rPr>
+              <a:t>Development of an AI-enabled Low Cost Real Time Mine Subsidence Monitoring, Prediction and Early Warning System for Underground Coal Mines in India.</a:t>
+            </a:r>
+          </a:p>
+          <a:p>
             <a:pPr>
               <a:buNone/>
               <a:defRPr sz="1800" b="1">
@@ -5097,7 +5151,7 @@
               </a:defRPr>
             </a:pPr>
             <a:r>
-              <a:rPr sz="3150" b="1">
+              <a:rPr lang="en-US" sz="3150" b="1" dirty="0">
                 <a:solidFill>
                   <a:srgbClr val="214E80"/>
                 </a:solidFill>
@@ -5105,65 +5159,7 @@
                 <a:ea typeface="Arial"/>
                 <a:cs typeface="Arial"/>
               </a:rPr>
-              <a:t>Problem Statement Title:-</a:t>
-            </a:r>
-          </a:p>
-        </p:txBody>
-      </p:sp>
-      <p:sp>
-        <p:nvSpPr>
-          <p:cNvPr id="45" name="Rectangle 44">
-            <a:extLst>
-              <a:ext uri="{FF2B5EF4-FFF2-40B4-BE49-F238E27FC236}">
-                <a16:creationId xmlns:a16="http://schemas.microsoft.com/office/drawing/2014/main" id="{F0851D41-8BCF-409E-B672-BC1D10D05792}"/>
-              </a:ext>
-            </a:extLst>
-          </p:cNvPr>
-          <p:cNvSpPr>
-            <a:spLocks noGrp="1"/>
-          </p:cNvSpPr>
-          <p:nvPr/>
-        </p:nvSpPr>
-        <p:spPr>
-          <a:xfrm>
-            <a:off x="5405438" y="4757737"/>
-            <a:ext cx="7955910" cy="2057400"/>
-          </a:xfrm>
-          <a:prstGeom prst="rect">
-            <a:avLst/>
-          </a:prstGeom>
-          <a:noFill/>
-          <a:ln w="0">
-            <a:noFill/>
-          </a:ln>
-        </p:spPr>
-        <p:txBody>
-          <a:bodyPr anchor="ctr">
-            <a:noAutofit/>
-          </a:bodyPr>
-          <a:lstStyle/>
-          <a:p>
-            <a:pPr>
-              <a:buNone/>
-              <a:defRPr sz="2025" b="0">
-                <a:solidFill>
-                  <a:srgbClr val="193247"/>
-                </a:solidFill>
-                <a:latin typeface="Arial"/>
-                <a:ea typeface="Arial"/>
-                <a:cs typeface="Arial"/>
-              </a:defRPr>
-            </a:pPr>
-            <a:r>
-              <a:rPr sz="3038">
-                <a:solidFill>
-                  <a:srgbClr val="193247"/>
-                </a:solidFill>
-                <a:latin typeface="Arial"/>
-                <a:ea typeface="Arial"/>
-                <a:cs typeface="Arial"/>
-              </a:rPr>
-              <a:t>Development of an AI-enabled Low Cost Real Time Mine Subsidence Monitoring, Prediction and Early Warning System for Underground Coal Mines in India.</a:t>
+              <a:t>        </a:t>
             </a:r>
           </a:p>
         </p:txBody>
@@ -5213,7 +5209,7 @@
               </a:defRPr>
             </a:pPr>
             <a:r>
-              <a:rPr sz="3150" b="1">
+              <a:rPr sz="3150" b="1" dirty="0">
                 <a:solidFill>
                   <a:srgbClr val="193247"/>
                 </a:solidFill>
@@ -5221,10 +5217,10 @@
                 <a:ea typeface="Arial"/>
                 <a:cs typeface="Arial"/>
               </a:rPr>
-              <a:t>Theme: </a:t>
-            </a:r>
-            <a:r>
-              <a:rPr sz="3150">
+              <a:t>Them</a:t>
+            </a:r>
+            <a:r>
+              <a:rPr lang="en-US" sz="3150" b="1" dirty="0">
                 <a:solidFill>
                   <a:srgbClr val="193247"/>
                 </a:solidFill>
@@ -5232,7 +5228,29 @@
                 <a:ea typeface="Arial"/>
                 <a:cs typeface="Arial"/>
               </a:rPr>
-              <a:t>							   Smart Automation</a:t>
+              <a:t>e: </a:t>
+            </a:r>
+            <a:r>
+              <a:rPr lang="en-US" sz="3150" dirty="0">
+                <a:solidFill>
+                  <a:srgbClr val="193247"/>
+                </a:solidFill>
+                <a:latin typeface="Arial"/>
+                <a:ea typeface="Arial"/>
+                <a:cs typeface="Arial"/>
+              </a:rPr>
+              <a:t>	</a:t>
+            </a:r>
+            <a:r>
+              <a:rPr sz="3150" dirty="0">
+                <a:solidFill>
+                  <a:srgbClr val="193247"/>
+                </a:solidFill>
+                <a:latin typeface="Arial"/>
+                <a:ea typeface="Arial"/>
+                <a:cs typeface="Arial"/>
+              </a:rPr>
+              <a:t>Smart Automation</a:t>
             </a:r>
           </a:p>
           <a:p>
@@ -5247,7 +5265,7 @@
                 <a:cs typeface="Arial"/>
               </a:defRPr>
             </a:pPr>
-            <a:endParaRPr sz="3150">
+            <a:endParaRPr sz="3150" dirty="0">
               <a:solidFill>
                 <a:srgbClr val="193247"/>
               </a:solidFill>
@@ -5269,7 +5287,7 @@
               </a:defRPr>
             </a:pPr>
             <a:r>
-              <a:rPr sz="3150" b="1">
+              <a:rPr sz="3150" b="1" dirty="0">
                 <a:solidFill>
                   <a:srgbClr val="193247"/>
                 </a:solidFill>
@@ -5277,10 +5295,10 @@
                 <a:ea typeface="Arial"/>
                 <a:cs typeface="Arial"/>
               </a:rPr>
-              <a:t>PS Category: 					   </a:t>
-            </a:r>
-            <a:r>
-              <a:rPr sz="3150">
+              <a:t>PS Category:  </a:t>
+            </a:r>
+            <a:r>
+              <a:rPr sz="3150" dirty="0">
                 <a:solidFill>
                   <a:srgbClr val="193247"/>
                 </a:solidFill>
@@ -5327,7 +5345,6 @@
           <a:lstStyle/>
           <a:p>
             <a:pPr>
-              <a:buNone/>
               <a:defRPr sz="1875" b="1">
                 <a:solidFill>
                   <a:srgbClr val="193247"/>
@@ -5338,20 +5355,30 @@
               </a:defRPr>
             </a:pPr>
             <a:r>
-              <a:rPr sz="3000" b="1">
+              <a:rPr sz="3000" b="1" dirty="0">
                 <a:solidFill>
                   <a:srgbClr val="193247"/>
                 </a:solidFill>
-                <a:latin typeface="Roboto Condensed"/>
+                <a:latin typeface="Arial" panose="020B0604020202020204" pitchFamily="34" charset="0"/>
                 <a:ea typeface="Roboto Condensed"/>
-                <a:cs typeface="Roboto Condensed"/>
-              </a:rPr>
-              <a:t>Team Name:  						   MineNova6</a:t>
+                <a:cs typeface="Arial" panose="020B0604020202020204" pitchFamily="34" charset="0"/>
+              </a:rPr>
+              <a:t>Team Name:  </a:t>
+            </a:r>
+            <a:r>
+              <a:rPr lang="en-US" sz="3000" dirty="0">
+                <a:solidFill>
+                  <a:srgbClr val="193247"/>
+                </a:solidFill>
+                <a:latin typeface="Arial" panose="020B0604020202020204" pitchFamily="34" charset="0"/>
+                <a:ea typeface="Roboto Condensed"/>
+                <a:cs typeface="Arial" panose="020B0604020202020204" pitchFamily="34" charset="0"/>
+              </a:rPr>
+              <a:t>MineNova6</a:t>
             </a:r>
           </a:p>
           <a:p>
             <a:pPr>
-              <a:buNone/>
               <a:defRPr sz="1875" b="1">
                 <a:solidFill>
                   <a:srgbClr val="193247"/>
@@ -5362,15 +5389,47 @@
               </a:defRPr>
             </a:pPr>
             <a:r>
-              <a:rPr sz="3000" b="1">
+              <a:rPr sz="3000" b="1" dirty="0">
                 <a:solidFill>
                   <a:srgbClr val="193247"/>
                 </a:solidFill>
-                <a:latin typeface="Roboto Condensed"/>
+                <a:latin typeface="Arial" panose="020B0604020202020204" pitchFamily="34" charset="0"/>
                 <a:ea typeface="Roboto Condensed"/>
-                <a:cs typeface="Roboto Condensed"/>
-              </a:rPr>
-              <a:t>Team ID:  [To be assigned]</a:t>
+                <a:cs typeface="Arial" panose="020B0604020202020204" pitchFamily="34" charset="0"/>
+              </a:rPr>
+              <a:t>					 </a:t>
+            </a:r>
+            <a:endParaRPr lang="en-US" sz="3000" b="1" dirty="0">
+              <a:solidFill>
+                <a:srgbClr val="193247"/>
+              </a:solidFill>
+              <a:latin typeface="Arial" panose="020B0604020202020204" pitchFamily="34" charset="0"/>
+              <a:ea typeface="Roboto Condensed"/>
+              <a:cs typeface="Arial" panose="020B0604020202020204" pitchFamily="34" charset="0"/>
+            </a:endParaRPr>
+          </a:p>
+          <a:p>
+            <a:pPr>
+              <a:buNone/>
+              <a:defRPr sz="1875" b="1">
+                <a:solidFill>
+                  <a:srgbClr val="193247"/>
+                </a:solidFill>
+                <a:latin typeface="Arial"/>
+                <a:ea typeface="Arial"/>
+                <a:cs typeface="Arial"/>
+              </a:defRPr>
+            </a:pPr>
+            <a:r>
+              <a:rPr sz="3000" b="1" dirty="0">
+                <a:solidFill>
+                  <a:srgbClr val="193247"/>
+                </a:solidFill>
+                <a:latin typeface="Arial" panose="020B0604020202020204" pitchFamily="34" charset="0"/>
+                <a:ea typeface="Roboto Condensed"/>
+                <a:cs typeface="Arial" panose="020B0604020202020204" pitchFamily="34" charset="0"/>
+              </a:rPr>
+              <a:t>Team ID:</a:t>
             </a:r>
           </a:p>
         </p:txBody>
@@ -11194,8 +11253,8 @@
         </p:nvSpPr>
         <p:spPr>
           <a:xfrm>
-            <a:off x="731520" y="2148840"/>
-            <a:ext cx="16824960" cy="7132320"/>
+            <a:off x="0" y="1958340"/>
+            <a:ext cx="17556480" cy="7642860"/>
           </a:xfrm>
           <a:prstGeom prst="roundRect">
             <a:avLst/>
@@ -11242,46 +11301,266 @@
                 <a:cs typeface="Arial"/>
               </a:defRPr>
             </a:pPr>
-            <a:r>
-              <a:rPr sz="1725" b="1">
-                <a:solidFill>
-                  <a:srgbClr val="152036"/>
-                </a:solidFill>
-                <a:latin typeface="Arial"/>
-                <a:ea typeface="Arial"/>
-                <a:cs typeface="Arial"/>
-                <a:hlinkClick r:id="rId4"/>
-              </a:rPr>
-              <a:t>[1] DGMS / Ministry of Labour &amp; Employment (2017)</a:t>
-            </a:r>
-            <a:r>
-              <a:rPr sz="1725" b="1">
-                <a:solidFill>
-                  <a:srgbClr val="152036"/>
-                </a:solidFill>
-                <a:latin typeface="Arial"/>
-                <a:ea typeface="Arial"/>
-                <a:cs typeface="Arial"/>
-              </a:rPr>
-              <a:t>  </a:t>
-            </a:r>
-            <a:r>
-              <a:rPr sz="1725" b="0">
-                <a:solidFill>
-                  <a:srgbClr val="152036"/>
-                </a:solidFill>
-                <a:latin typeface="Arial"/>
-                <a:ea typeface="Arial"/>
-                <a:cs typeface="Arial"/>
-              </a:rPr>
-              <a:t>The Coal Mines Regulations, 2017. Reg. 111: Development work. Reg. 112: Depillaring operations. Official Gazette text.</a:t>
-            </a:r>
-          </a:p>
-          <a:p>
-            <a:pPr algn="l">
+            <a:endParaRPr sz="1725" b="0" dirty="0">
+              <a:solidFill>
+                <a:srgbClr val="152036"/>
+              </a:solidFill>
+              <a:latin typeface="Arial"/>
+              <a:ea typeface="Arial"/>
+              <a:cs typeface="Arial"/>
+            </a:endParaRPr>
+          </a:p>
+        </p:txBody>
+      </p:sp>
+      <p:sp>
+        <p:nvSpPr>
+          <p:cNvPr id="11" name="Rectangle 10">
+            <a:hlinkClick r:id="rId4"/>
+            <a:extLst>
+              <a:ext uri="{FF2B5EF4-FFF2-40B4-BE49-F238E27FC236}">
+                <a16:creationId xmlns:a16="http://schemas.microsoft.com/office/drawing/2014/main" id="{196655BB-CF55-484B-ADD8-F66FF3B9A61F}"/>
+              </a:ext>
+            </a:extLst>
+          </p:cNvPr>
+          <p:cNvSpPr/>
+          <p:nvPr/>
+        </p:nvSpPr>
+        <p:spPr>
+          <a:xfrm>
+            <a:off x="1214004" y="8385810"/>
+            <a:ext cx="16192500" cy="381000"/>
+          </a:xfrm>
+          <a:prstGeom prst="rect">
+            <a:avLst/>
+          </a:prstGeom>
+          <a:noFill/>
+          <a:ln w="9525" cap="flat" cmpd="sng" algn="ctr">
+            <a:noFill/>
+            <a:prstDash val="solid"/>
+          </a:ln>
+          <a:effectLst/>
+          <a:extLst>
+            <a:ext uri="{909E8E84-426E-40DD-AFC4-6F175D3DCCD1}">
+              <a14:hiddenFill xmlns:a14="http://schemas.microsoft.com/office/drawing/2010/main">
+                <a:gradFill rotWithShape="1">
+                  <a:gsLst>
+                    <a:gs pos="0">
+                      <a:schemeClr val="accent1">
+                        <a:tint val="100000"/>
+                        <a:shade val="100000"/>
+                        <a:satMod val="130000"/>
+                      </a:schemeClr>
+                    </a:gs>
+                    <a:gs pos="100000">
+                      <a:schemeClr val="accent1">
+                        <a:tint val="50000"/>
+                        <a:shade val="100000"/>
+                        <a:satMod val="350000"/>
+                      </a:schemeClr>
+                    </a:gs>
+                  </a:gsLst>
+                  <a:lin ang="16200000" scaled="0"/>
+                </a:gradFill>
+              </a14:hiddenFill>
+            </a:ext>
+            <a:ext uri="{91240B29-F687-4F45-9708-019B960494DF}">
+              <a14:hiddenLine xmlns:a14="http://schemas.microsoft.com/office/drawing/2010/main" w="9525" cap="flat" cmpd="sng" algn="ctr">
+                <a:solidFill>
+                  <a:schemeClr val="accent1">
+                    <a:shade val="95000"/>
+                    <a:satMod val="105000"/>
+                  </a:schemeClr>
+                </a:solidFill>
+                <a:prstDash val="solid"/>
+              </a14:hiddenLine>
+            </a:ext>
+            <a:ext uri="{AF507438-7753-43E0-B8FC-AC1667EBCBE1}">
+              <a14:hiddenEffects xmlns:a14="http://schemas.microsoft.com/office/drawing/2010/main">
+                <a:effectLst>
+                  <a:outerShdw blurRad="40000" dist="23000" dir="5400000" rotWithShape="0">
+                    <a:srgbClr val="000000">
+                      <a:alpha val="35000"/>
+                    </a:srgbClr>
+                  </a:outerShdw>
+                </a:effectLst>
+              </a14:hiddenEffects>
+            </a:ext>
+          </a:extLst>
+        </p:spPr>
+        <p:style>
+          <a:lnRef idx="1">
+            <a:schemeClr val="accent1"/>
+          </a:lnRef>
+          <a:fillRef idx="3">
+            <a:schemeClr val="accent1"/>
+          </a:fillRef>
+          <a:effectRef idx="2">
+            <a:schemeClr val="accent1"/>
+          </a:effectRef>
+          <a:fontRef idx="minor">
+            <a:schemeClr val="lt1"/>
+          </a:fontRef>
+        </p:style>
+        <p:txBody>
+          <a:bodyPr rtlCol="0" anchor="t"/>
+          <a:lstStyle/>
+          <a:p>
+            <a:endParaRPr lang="en-US" dirty="0">
+              <a:solidFill>
+                <a:srgbClr val="193247"/>
+              </a:solidFill>
+              <a:latin typeface="Arial" panose="020B0604020202020204" pitchFamily="34" charset="0"/>
+              <a:cs typeface="Arial" panose="020B0604020202020204" pitchFamily="34" charset="0"/>
+            </a:endParaRPr>
+          </a:p>
+        </p:txBody>
+      </p:sp>
+      <p:sp>
+        <p:nvSpPr>
+          <p:cNvPr id="12" name="Rectangle 11">
+            <a:hlinkClick r:id="rId5"/>
+            <a:extLst>
+              <a:ext uri="{FF2B5EF4-FFF2-40B4-BE49-F238E27FC236}">
+                <a16:creationId xmlns:a16="http://schemas.microsoft.com/office/drawing/2014/main" id="{DB480DFE-A4D4-4EAC-84DF-42DFF9555322}"/>
+              </a:ext>
+            </a:extLst>
+          </p:cNvPr>
+          <p:cNvSpPr/>
+          <p:nvPr/>
+        </p:nvSpPr>
+        <p:spPr>
+          <a:xfrm>
+            <a:off x="1214004" y="8823960"/>
+            <a:ext cx="16192500" cy="381000"/>
+          </a:xfrm>
+          <a:prstGeom prst="rect">
+            <a:avLst/>
+          </a:prstGeom>
+          <a:noFill/>
+          <a:ln w="9525" cap="flat" cmpd="sng" algn="ctr">
+            <a:noFill/>
+            <a:prstDash val="solid"/>
+          </a:ln>
+          <a:effectLst/>
+          <a:extLst>
+            <a:ext uri="{909E8E84-426E-40DD-AFC4-6F175D3DCCD1}">
+              <a14:hiddenFill xmlns:a14="http://schemas.microsoft.com/office/drawing/2010/main">
+                <a:gradFill rotWithShape="1">
+                  <a:gsLst>
+                    <a:gs pos="0">
+                      <a:schemeClr val="accent1">
+                        <a:tint val="100000"/>
+                        <a:shade val="100000"/>
+                        <a:satMod val="130000"/>
+                      </a:schemeClr>
+                    </a:gs>
+                    <a:gs pos="100000">
+                      <a:schemeClr val="accent1">
+                        <a:tint val="50000"/>
+                        <a:shade val="100000"/>
+                        <a:satMod val="350000"/>
+                      </a:schemeClr>
+                    </a:gs>
+                  </a:gsLst>
+                  <a:lin ang="16200000" scaled="0"/>
+                </a:gradFill>
+              </a14:hiddenFill>
+            </a:ext>
+            <a:ext uri="{91240B29-F687-4F45-9708-019B960494DF}">
+              <a14:hiddenLine xmlns:a14="http://schemas.microsoft.com/office/drawing/2010/main" w="9525" cap="flat" cmpd="sng" algn="ctr">
+                <a:solidFill>
+                  <a:schemeClr val="accent1">
+                    <a:shade val="95000"/>
+                    <a:satMod val="105000"/>
+                  </a:schemeClr>
+                </a:solidFill>
+                <a:prstDash val="solid"/>
+              </a14:hiddenLine>
+            </a:ext>
+            <a:ext uri="{AF507438-7753-43E0-B8FC-AC1667EBCBE1}">
+              <a14:hiddenEffects xmlns:a14="http://schemas.microsoft.com/office/drawing/2010/main">
+                <a:effectLst>
+                  <a:outerShdw blurRad="40000" dist="23000" dir="5400000" rotWithShape="0">
+                    <a:srgbClr val="000000">
+                      <a:alpha val="35000"/>
+                    </a:srgbClr>
+                  </a:outerShdw>
+                </a:effectLst>
+              </a14:hiddenEffects>
+            </a:ext>
+          </a:extLst>
+        </p:spPr>
+        <p:style>
+          <a:lnRef idx="1">
+            <a:schemeClr val="accent1"/>
+          </a:lnRef>
+          <a:fillRef idx="3">
+            <a:schemeClr val="accent1"/>
+          </a:fillRef>
+          <a:effectRef idx="2">
+            <a:schemeClr val="accent1"/>
+          </a:effectRef>
+          <a:fontRef idx="minor">
+            <a:schemeClr val="lt1"/>
+          </a:fontRef>
+        </p:style>
+        <p:txBody>
+          <a:bodyPr rtlCol="0" anchor="t"/>
+          <a:lstStyle/>
+          <a:p>
+            <a:endParaRPr lang="en-US" dirty="0">
+              <a:solidFill>
+                <a:srgbClr val="193247"/>
+              </a:solidFill>
+              <a:latin typeface="Arial" panose="020B0604020202020204" pitchFamily="34" charset="0"/>
+              <a:cs typeface="Arial" panose="020B0604020202020204" pitchFamily="34" charset="0"/>
+            </a:endParaRPr>
+          </a:p>
+        </p:txBody>
+      </p:sp>
+      <p:sp>
+        <p:nvSpPr>
+          <p:cNvPr id="4" name="TextBox 3">
+            <a:extLst>
+              <a:ext uri="{FF2B5EF4-FFF2-40B4-BE49-F238E27FC236}">
+                <a16:creationId xmlns:a16="http://schemas.microsoft.com/office/drawing/2014/main" id="{197662AA-8AAC-4006-84F8-D0E4CE11318D}"/>
+              </a:ext>
+            </a:extLst>
+          </p:cNvPr>
+          <p:cNvSpPr txBox="1"/>
+          <p:nvPr/>
+        </p:nvSpPr>
+        <p:spPr>
+          <a:xfrm>
+            <a:off x="1064028" y="2644140"/>
+            <a:ext cx="14663304" cy="7377661"/>
+          </a:xfrm>
+          <a:prstGeom prst="rect">
+            <a:avLst/>
+          </a:prstGeom>
+          <a:noFill/>
+        </p:spPr>
+        <p:txBody>
+          <a:bodyPr wrap="square" rtlCol="0">
+            <a:spAutoFit/>
+          </a:bodyPr>
+          <a:lstStyle/>
+          <a:p>
+            <a:pPr marL="0" marR="0" lvl="0" indent="0" algn="l" defTabSz="914400" rtl="0" eaLnBrk="1" fontAlgn="auto" latinLnBrk="0" hangingPunct="1">
+              <a:lnSpc>
+                <a:spcPct val="100000"/>
+              </a:lnSpc>
+              <a:spcBef>
+                <a:spcPts val="0"/>
+              </a:spcBef>
               <a:spcAft>
                 <a:spcPts val="1600"/>
               </a:spcAft>
+              <a:buClrTx/>
+              <a:buSzTx/>
+              <a:buFontTx/>
+              <a:buNone/>
+              <a:tabLst/>
               <a:defRPr sz="1725">
                 <a:solidFill>
                   <a:srgbClr val="152036"/>
@@ -11292,22 +11571,70 @@
               </a:defRPr>
             </a:pPr>
             <a:r>
-              <a:rPr sz="1725" b="1">
-                <a:solidFill>
-                  <a:srgbClr val="152036"/>
-                </a:solidFill>
-                <a:latin typeface="Arial"/>
-                <a:ea typeface="Arial"/>
-                <a:cs typeface="Arial"/>
-                <a:hlinkClick r:id="rId5"/>
-              </a:rPr>
-              <a:t>[2] Ministry of Coal (25 June 2025)</a:t>
-            </a:r>
-            <a:r>
-              <a:rPr sz="1725" b="1">
-                <a:solidFill>
-                  <a:srgbClr val="152036"/>
-                </a:solidFill>
+              <a:rPr kumimoji="0" lang="en-US" sz="1725" b="1" i="0" u="none" strike="noStrike" kern="1200" cap="none" spc="0" normalizeH="0" baseline="0" noProof="0" dirty="0">
+                <a:ln>
+                  <a:noFill/>
+                </a:ln>
+                <a:solidFill>
+                  <a:srgbClr val="152036"/>
+                </a:solidFill>
+                <a:effectLst/>
+                <a:uLnTx/>
+                <a:uFillTx/>
+                <a:latin typeface="Arial"/>
+                <a:ea typeface="Arial"/>
+                <a:cs typeface="Arial"/>
+                <a:hlinkClick r:id="rId6"/>
+              </a:rPr>
+              <a:t>[1] DGMS / Ministry of </a:t>
+            </a:r>
+            <a:r>
+              <a:rPr kumimoji="0" lang="en-US" sz="1725" b="1" i="0" u="none" strike="noStrike" kern="1200" cap="none" spc="0" normalizeH="0" baseline="0" noProof="0" dirty="0" err="1">
+                <a:ln>
+                  <a:noFill/>
+                </a:ln>
+                <a:solidFill>
+                  <a:srgbClr val="152036"/>
+                </a:solidFill>
+                <a:effectLst/>
+                <a:uLnTx/>
+                <a:uFillTx/>
+                <a:latin typeface="Arial"/>
+                <a:ea typeface="Arial"/>
+                <a:cs typeface="Arial"/>
+                <a:hlinkClick r:id="rId6"/>
+              </a:rPr>
+              <a:t>Labour</a:t>
+            </a:r>
+            <a:r>
+              <a:rPr kumimoji="0" lang="en-US" sz="1725" b="1" i="0" u="none" strike="noStrike" kern="1200" cap="none" spc="0" normalizeH="0" baseline="0" noProof="0" dirty="0">
+                <a:ln>
+                  <a:noFill/>
+                </a:ln>
+                <a:solidFill>
+                  <a:srgbClr val="152036"/>
+                </a:solidFill>
+                <a:effectLst/>
+                <a:uLnTx/>
+                <a:uFillTx/>
+                <a:latin typeface="Arial"/>
+                <a:ea typeface="Arial"/>
+                <a:cs typeface="Arial"/>
+                <a:hlinkClick r:id="rId6"/>
+              </a:rPr>
+              <a:t> &amp; Employment (2017)</a:t>
+            </a:r>
+            <a:r>
+              <a:rPr kumimoji="0" lang="en-US" sz="1725" b="1" i="0" u="none" strike="noStrike" kern="1200" cap="none" spc="0" normalizeH="0" baseline="0" noProof="0" dirty="0">
+                <a:ln>
+                  <a:noFill/>
+                </a:ln>
+                <a:solidFill>
+                  <a:srgbClr val="152036"/>
+                </a:solidFill>
+                <a:effectLst/>
+                <a:uLnTx/>
+                <a:uFillTx/>
                 <a:latin typeface="Arial"/>
                 <a:ea typeface="Arial"/>
                 <a:cs typeface="Arial"/>
@@ -11315,22 +11642,39 @@
               <a:t>  </a:t>
             </a:r>
             <a:r>
-              <a:rPr sz="1725" b="0">
-                <a:solidFill>
-                  <a:srgbClr val="152036"/>
-                </a:solidFill>
-                <a:latin typeface="Arial"/>
-                <a:ea typeface="Arial"/>
-                <a:cs typeface="Arial"/>
-              </a:rPr>
-              <a:t>Cabinet approval of the Revised Jharia Master Plan for fire, subsidence and rehabilitation. Release ID 2139495.</a:t>
-            </a:r>
-          </a:p>
-          <a:p>
-            <a:pPr algn="l">
+              <a:rPr kumimoji="0" lang="en-US" sz="1725" b="0" i="0" u="none" strike="noStrike" kern="1200" cap="none" spc="0" normalizeH="0" baseline="0" noProof="0" dirty="0">
+                <a:ln>
+                  <a:noFill/>
+                </a:ln>
+                <a:solidFill>
+                  <a:srgbClr val="152036"/>
+                </a:solidFill>
+                <a:effectLst/>
+                <a:uLnTx/>
+                <a:uFillTx/>
+                <a:latin typeface="Arial"/>
+                <a:ea typeface="Arial"/>
+                <a:cs typeface="Arial"/>
+              </a:rPr>
+              <a:t>The Coal Mines Regulations, 2017. Reg. 111: Development work. Reg. 112: Depillaring operations. Official Gazette text.</a:t>
+            </a:r>
+          </a:p>
+          <a:p>
+            <a:pPr marL="0" marR="0" lvl="0" indent="0" algn="l" defTabSz="914400" rtl="0" eaLnBrk="1" fontAlgn="auto" latinLnBrk="0" hangingPunct="1">
+              <a:lnSpc>
+                <a:spcPct val="100000"/>
+              </a:lnSpc>
+              <a:spcBef>
+                <a:spcPts val="0"/>
+              </a:spcBef>
               <a:spcAft>
                 <a:spcPts val="1600"/>
               </a:spcAft>
+              <a:buClrTx/>
+              <a:buSzTx/>
+              <a:buFontTx/>
+              <a:buNone/>
+              <a:tabLst/>
               <a:defRPr sz="1725">
                 <a:solidFill>
                   <a:srgbClr val="152036"/>
@@ -11341,22 +11685,34 @@
               </a:defRPr>
             </a:pPr>
             <a:r>
-              <a:rPr sz="1725" b="1">
-                <a:solidFill>
-                  <a:srgbClr val="152036"/>
-                </a:solidFill>
-                <a:latin typeface="Arial"/>
-                <a:ea typeface="Arial"/>
-                <a:cs typeface="Arial"/>
-                <a:hlinkClick r:id="rId6"/>
-              </a:rPr>
-              <a:t>[3] Misa, R. (2023)</a:t>
-            </a:r>
-            <a:r>
-              <a:rPr sz="1725" b="1">
-                <a:solidFill>
-                  <a:srgbClr val="152036"/>
-                </a:solidFill>
+              <a:rPr kumimoji="0" lang="en-US" sz="1725" b="1" i="0" u="none" strike="noStrike" kern="1200" cap="none" spc="0" normalizeH="0" baseline="0" noProof="0" dirty="0">
+                <a:ln>
+                  <a:noFill/>
+                </a:ln>
+                <a:solidFill>
+                  <a:srgbClr val="152036"/>
+                </a:solidFill>
+                <a:effectLst/>
+                <a:uLnTx/>
+                <a:uFillTx/>
+                <a:latin typeface="Arial"/>
+                <a:ea typeface="Arial"/>
+                <a:cs typeface="Arial"/>
+                <a:hlinkClick r:id="rId7"/>
+              </a:rPr>
+              <a:t>[2] Ministry of Coal (25 June 2025)</a:t>
+            </a:r>
+            <a:r>
+              <a:rPr kumimoji="0" lang="en-US" sz="1725" b="1" i="0" u="none" strike="noStrike" kern="1200" cap="none" spc="0" normalizeH="0" baseline="0" noProof="0" dirty="0">
+                <a:ln>
+                  <a:noFill/>
+                </a:ln>
+                <a:solidFill>
+                  <a:srgbClr val="152036"/>
+                </a:solidFill>
+                <a:effectLst/>
+                <a:uLnTx/>
+                <a:uFillTx/>
                 <a:latin typeface="Arial"/>
                 <a:ea typeface="Arial"/>
                 <a:cs typeface="Arial"/>
@@ -11364,22 +11720,73 @@
               <a:t>  </a:t>
             </a:r>
             <a:r>
-              <a:rPr sz="1725" b="0">
-                <a:solidFill>
-                  <a:srgbClr val="152036"/>
-                </a:solidFill>
-                <a:latin typeface="Arial"/>
-                <a:ea typeface="Arial"/>
-                <a:cs typeface="Arial"/>
-              </a:rPr>
-              <a:t>Knothe’s theory parameters – computational models and examples of practical applications. Mineral Resources Management 39(4), 157–180. DOI: 10.24425/gsm.2023.148164.</a:t>
-            </a:r>
-          </a:p>
-          <a:p>
-            <a:pPr algn="l">
+              <a:rPr kumimoji="0" lang="en-US" sz="1725" b="0" i="0" u="none" strike="noStrike" kern="1200" cap="none" spc="0" normalizeH="0" baseline="0" noProof="0" dirty="0">
+                <a:ln>
+                  <a:noFill/>
+                </a:ln>
+                <a:solidFill>
+                  <a:srgbClr val="152036"/>
+                </a:solidFill>
+                <a:effectLst/>
+                <a:uLnTx/>
+                <a:uFillTx/>
+                <a:latin typeface="Arial"/>
+                <a:ea typeface="Arial"/>
+                <a:cs typeface="Arial"/>
+              </a:rPr>
+              <a:t>Cabinet approval of the Revised </a:t>
+            </a:r>
+            <a:r>
+              <a:rPr kumimoji="0" lang="en-US" sz="1725" b="0" i="0" u="none" strike="noStrike" kern="1200" cap="none" spc="0" normalizeH="0" baseline="0" noProof="0" dirty="0" err="1">
+                <a:ln>
+                  <a:noFill/>
+                </a:ln>
+                <a:solidFill>
+                  <a:srgbClr val="152036"/>
+                </a:solidFill>
+                <a:effectLst/>
+                <a:uLnTx/>
+                <a:uFillTx/>
+                <a:latin typeface="Arial"/>
+                <a:ea typeface="Arial"/>
+                <a:cs typeface="Arial"/>
+              </a:rPr>
+              <a:t>Jharia</a:t>
+            </a:r>
+            <a:r>
+              <a:rPr kumimoji="0" lang="en-US" sz="1725" b="0" i="0" u="none" strike="noStrike" kern="1200" cap="none" spc="0" normalizeH="0" baseline="0" noProof="0" dirty="0">
+                <a:ln>
+                  <a:noFill/>
+                </a:ln>
+                <a:solidFill>
+                  <a:srgbClr val="152036"/>
+                </a:solidFill>
+                <a:effectLst/>
+                <a:uLnTx/>
+                <a:uFillTx/>
+                <a:latin typeface="Arial"/>
+                <a:ea typeface="Arial"/>
+                <a:cs typeface="Arial"/>
+              </a:rPr>
+              <a:t> Master Plan for fire, subsidence and rehabilitation. Release ID 2139495.</a:t>
+            </a:r>
+          </a:p>
+          <a:p>
+            <a:pPr marL="0" marR="0" lvl="0" indent="0" algn="l" defTabSz="914400" rtl="0" eaLnBrk="1" fontAlgn="auto" latinLnBrk="0" hangingPunct="1">
+              <a:lnSpc>
+                <a:spcPct val="100000"/>
+              </a:lnSpc>
+              <a:spcBef>
+                <a:spcPts val="0"/>
+              </a:spcBef>
               <a:spcAft>
                 <a:spcPts val="1600"/>
               </a:spcAft>
+              <a:buClrTx/>
+              <a:buSzTx/>
+              <a:buFontTx/>
+              <a:buNone/>
+              <a:tabLst/>
               <a:defRPr sz="1725">
                 <a:solidFill>
                   <a:srgbClr val="152036"/>
@@ -11390,22 +11797,34 @@
               </a:defRPr>
             </a:pPr>
             <a:r>
-              <a:rPr sz="1725" b="1">
-                <a:solidFill>
-                  <a:srgbClr val="152036"/>
-                </a:solidFill>
-                <a:latin typeface="Arial"/>
-                <a:ea typeface="Arial"/>
-                <a:cs typeface="Arial"/>
-                <a:hlinkClick r:id="rId7"/>
-              </a:rPr>
-              <a:t>[4] Saito, M. (1965)</a:t>
-            </a:r>
-            <a:r>
-              <a:rPr sz="1725" b="1">
-                <a:solidFill>
-                  <a:srgbClr val="152036"/>
-                </a:solidFill>
+              <a:rPr kumimoji="0" lang="en-US" sz="1725" b="1" i="0" u="none" strike="noStrike" kern="1200" cap="none" spc="0" normalizeH="0" baseline="0" noProof="0" dirty="0">
+                <a:ln>
+                  <a:noFill/>
+                </a:ln>
+                <a:solidFill>
+                  <a:srgbClr val="152036"/>
+                </a:solidFill>
+                <a:effectLst/>
+                <a:uLnTx/>
+                <a:uFillTx/>
+                <a:latin typeface="Arial"/>
+                <a:ea typeface="Arial"/>
+                <a:cs typeface="Arial"/>
+                <a:hlinkClick r:id="rId8"/>
+              </a:rPr>
+              <a:t>[3] Misa, R. (2023)</a:t>
+            </a:r>
+            <a:r>
+              <a:rPr kumimoji="0" lang="en-US" sz="1725" b="1" i="0" u="none" strike="noStrike" kern="1200" cap="none" spc="0" normalizeH="0" baseline="0" noProof="0" dirty="0">
+                <a:ln>
+                  <a:noFill/>
+                </a:ln>
+                <a:solidFill>
+                  <a:srgbClr val="152036"/>
+                </a:solidFill>
+                <a:effectLst/>
+                <a:uLnTx/>
+                <a:uFillTx/>
                 <a:latin typeface="Arial"/>
                 <a:ea typeface="Arial"/>
                 <a:cs typeface="Arial"/>
@@ -11413,22 +11832,56 @@
               <a:t>  </a:t>
             </a:r>
             <a:r>
-              <a:rPr sz="1725" b="0">
-                <a:solidFill>
-                  <a:srgbClr val="152036"/>
-                </a:solidFill>
-                <a:latin typeface="Arial"/>
-                <a:ea typeface="Arial"/>
-                <a:cs typeface="Arial"/>
-              </a:rPr>
-              <a:t>Forecasting the Time of Occurrence of a Slope Failure. Proceedings, 6th ICSMFE, Montréal, Vol. 2, pp. 537–541. ISSMGE archive.</a:t>
-            </a:r>
-          </a:p>
-          <a:p>
-            <a:pPr algn="l">
+              <a:rPr kumimoji="0" lang="en-US" sz="1725" b="0" i="0" u="none" strike="noStrike" kern="1200" cap="none" spc="0" normalizeH="0" baseline="0" noProof="0" dirty="0" err="1">
+                <a:ln>
+                  <a:noFill/>
+                </a:ln>
+                <a:solidFill>
+                  <a:srgbClr val="152036"/>
+                </a:solidFill>
+                <a:effectLst/>
+                <a:uLnTx/>
+                <a:uFillTx/>
+                <a:latin typeface="Arial"/>
+                <a:ea typeface="Arial"/>
+                <a:cs typeface="Arial"/>
+              </a:rPr>
+              <a:t>Knothe’s</a:t>
+            </a:r>
+            <a:r>
+              <a:rPr kumimoji="0" lang="en-US" sz="1725" b="0" i="0" u="none" strike="noStrike" kern="1200" cap="none" spc="0" normalizeH="0" baseline="0" noProof="0" dirty="0">
+                <a:ln>
+                  <a:noFill/>
+                </a:ln>
+                <a:solidFill>
+                  <a:srgbClr val="152036"/>
+                </a:solidFill>
+                <a:effectLst/>
+                <a:uLnTx/>
+                <a:uFillTx/>
+                <a:latin typeface="Arial"/>
+                <a:ea typeface="Arial"/>
+                <a:cs typeface="Arial"/>
+              </a:rPr>
+              <a:t> theory parameters – computational models and examples of practical applications. Mineral Resources Management 39(4), 157–180. DOI: 10.24425/gsm.2023.148164.</a:t>
+            </a:r>
+          </a:p>
+          <a:p>
+            <a:pPr marL="0" marR="0" lvl="0" indent="0" algn="l" defTabSz="914400" rtl="0" eaLnBrk="1" fontAlgn="auto" latinLnBrk="0" hangingPunct="1">
+              <a:lnSpc>
+                <a:spcPct val="100000"/>
+              </a:lnSpc>
+              <a:spcBef>
+                <a:spcPts val="0"/>
+              </a:spcBef>
               <a:spcAft>
                 <a:spcPts val="1600"/>
               </a:spcAft>
+              <a:buClrTx/>
+              <a:buSzTx/>
+              <a:buFontTx/>
+              <a:buNone/>
+              <a:tabLst/>
               <a:defRPr sz="1725">
                 <a:solidFill>
                   <a:srgbClr val="152036"/>
@@ -11439,22 +11892,34 @@
               </a:defRPr>
             </a:pPr>
             <a:r>
-              <a:rPr sz="1725" b="1">
-                <a:solidFill>
-                  <a:srgbClr val="152036"/>
-                </a:solidFill>
-                <a:latin typeface="Arial"/>
-                <a:ea typeface="Arial"/>
-                <a:cs typeface="Arial"/>
-                <a:hlinkClick r:id="rId8"/>
-              </a:rPr>
-              <a:t>[5] Fukuzono, T. (1985)</a:t>
-            </a:r>
-            <a:r>
-              <a:rPr sz="1725" b="1">
-                <a:solidFill>
-                  <a:srgbClr val="152036"/>
-                </a:solidFill>
+              <a:rPr kumimoji="0" lang="en-US" sz="1725" b="1" i="0" u="none" strike="noStrike" kern="1200" cap="none" spc="0" normalizeH="0" baseline="0" noProof="0" dirty="0">
+                <a:ln>
+                  <a:noFill/>
+                </a:ln>
+                <a:solidFill>
+                  <a:srgbClr val="152036"/>
+                </a:solidFill>
+                <a:effectLst/>
+                <a:uLnTx/>
+                <a:uFillTx/>
+                <a:latin typeface="Arial"/>
+                <a:ea typeface="Arial"/>
+                <a:cs typeface="Arial"/>
+                <a:hlinkClick r:id="rId9"/>
+              </a:rPr>
+              <a:t>[4] Saito, M. (1965)</a:t>
+            </a:r>
+            <a:r>
+              <a:rPr kumimoji="0" lang="en-US" sz="1725" b="1" i="0" u="none" strike="noStrike" kern="1200" cap="none" spc="0" normalizeH="0" baseline="0" noProof="0" dirty="0">
+                <a:ln>
+                  <a:noFill/>
+                </a:ln>
+                <a:solidFill>
+                  <a:srgbClr val="152036"/>
+                </a:solidFill>
+                <a:effectLst/>
+                <a:uLnTx/>
+                <a:uFillTx/>
                 <a:latin typeface="Arial"/>
                 <a:ea typeface="Arial"/>
                 <a:cs typeface="Arial"/>
@@ -11462,22 +11927,39 @@
               <a:t>  </a:t>
             </a:r>
             <a:r>
-              <a:rPr sz="1725" b="0">
-                <a:solidFill>
-                  <a:srgbClr val="152036"/>
-                </a:solidFill>
-                <a:latin typeface="Arial"/>
-                <a:ea typeface="Arial"/>
-                <a:cs typeface="Arial"/>
-              </a:rPr>
-              <a:t>A Method to Predict the Time of Slope Failure Caused by Rainfall Using the Inverse Number of Velocity of Surface Displacement. Landslides 22(2), 8–13. DOI: 10.3313/jls1964.22.2_8.</a:t>
-            </a:r>
-          </a:p>
-          <a:p>
-            <a:pPr algn="l">
+              <a:rPr kumimoji="0" lang="en-US" sz="1725" b="0" i="0" u="none" strike="noStrike" kern="1200" cap="none" spc="0" normalizeH="0" baseline="0" noProof="0" dirty="0">
+                <a:ln>
+                  <a:noFill/>
+                </a:ln>
+                <a:solidFill>
+                  <a:srgbClr val="152036"/>
+                </a:solidFill>
+                <a:effectLst/>
+                <a:uLnTx/>
+                <a:uFillTx/>
+                <a:latin typeface="Arial"/>
+                <a:ea typeface="Arial"/>
+                <a:cs typeface="Arial"/>
+              </a:rPr>
+              <a:t>Forecasting the Time of Occurrence of a Slope Failure. Proceedings, 6th ICSMFE, Montréal, Vol. 2, pp. 537–541. ISSMGE archive.</a:t>
+            </a:r>
+          </a:p>
+          <a:p>
+            <a:pPr marL="0" marR="0" lvl="0" indent="0" algn="l" defTabSz="914400" rtl="0" eaLnBrk="1" fontAlgn="auto" latinLnBrk="0" hangingPunct="1">
+              <a:lnSpc>
+                <a:spcPct val="100000"/>
+              </a:lnSpc>
+              <a:spcBef>
+                <a:spcPts val="0"/>
+              </a:spcBef>
               <a:spcAft>
                 <a:spcPts val="1600"/>
               </a:spcAft>
+              <a:buClrTx/>
+              <a:buSzTx/>
+              <a:buFontTx/>
+              <a:buNone/>
+              <a:tabLst/>
               <a:defRPr sz="1725">
                 <a:solidFill>
                   <a:srgbClr val="152036"/>
@@ -11488,22 +11970,70 @@
               </a:defRPr>
             </a:pPr>
             <a:r>
-              <a:rPr sz="1725" b="1">
-                <a:solidFill>
-                  <a:srgbClr val="152036"/>
-                </a:solidFill>
-                <a:latin typeface="Arial"/>
-                <a:ea typeface="Arial"/>
-                <a:cs typeface="Arial"/>
-                <a:hlinkClick r:id="rId9"/>
-              </a:rPr>
-              <a:t>[6] Department of Telecommunications / WPC (2021)</a:t>
-            </a:r>
-            <a:r>
-              <a:rPr sz="1725" b="1">
-                <a:solidFill>
-                  <a:srgbClr val="152036"/>
-                </a:solidFill>
+              <a:rPr kumimoji="0" lang="en-US" sz="1725" b="1" i="0" u="none" strike="noStrike" kern="1200" cap="none" spc="0" normalizeH="0" baseline="0" noProof="0" dirty="0">
+                <a:ln>
+                  <a:noFill/>
+                </a:ln>
+                <a:solidFill>
+                  <a:srgbClr val="152036"/>
+                </a:solidFill>
+                <a:effectLst/>
+                <a:uLnTx/>
+                <a:uFillTx/>
+                <a:latin typeface="Arial"/>
+                <a:ea typeface="Arial"/>
+                <a:cs typeface="Arial"/>
+                <a:hlinkClick r:id="rId10"/>
+              </a:rPr>
+              <a:t>[5] </a:t>
+            </a:r>
+            <a:r>
+              <a:rPr kumimoji="0" lang="en-US" sz="1725" b="1" i="0" u="none" strike="noStrike" kern="1200" cap="none" spc="0" normalizeH="0" baseline="0" noProof="0" dirty="0" err="1">
+                <a:ln>
+                  <a:noFill/>
+                </a:ln>
+                <a:solidFill>
+                  <a:srgbClr val="152036"/>
+                </a:solidFill>
+                <a:effectLst/>
+                <a:uLnTx/>
+                <a:uFillTx/>
+                <a:latin typeface="Arial"/>
+                <a:ea typeface="Arial"/>
+                <a:cs typeface="Arial"/>
+                <a:hlinkClick r:id="rId10"/>
+              </a:rPr>
+              <a:t>Fukuzono</a:t>
+            </a:r>
+            <a:r>
+              <a:rPr kumimoji="0" lang="en-US" sz="1725" b="1" i="0" u="none" strike="noStrike" kern="1200" cap="none" spc="0" normalizeH="0" baseline="0" noProof="0" dirty="0">
+                <a:ln>
+                  <a:noFill/>
+                </a:ln>
+                <a:solidFill>
+                  <a:srgbClr val="152036"/>
+                </a:solidFill>
+                <a:effectLst/>
+                <a:uLnTx/>
+                <a:uFillTx/>
+                <a:latin typeface="Arial"/>
+                <a:ea typeface="Arial"/>
+                <a:cs typeface="Arial"/>
+                <a:hlinkClick r:id="rId10"/>
+              </a:rPr>
+              <a:t>, T. (1985)</a:t>
+            </a:r>
+            <a:r>
+              <a:rPr kumimoji="0" lang="en-US" sz="1725" b="1" i="0" u="none" strike="noStrike" kern="1200" cap="none" spc="0" normalizeH="0" baseline="0" noProof="0" dirty="0">
+                <a:ln>
+                  <a:noFill/>
+                </a:ln>
+                <a:solidFill>
+                  <a:srgbClr val="152036"/>
+                </a:solidFill>
+                <a:effectLst/>
+                <a:uLnTx/>
+                <a:uFillTx/>
                 <a:latin typeface="Arial"/>
                 <a:ea typeface="Arial"/>
                 <a:cs typeface="Arial"/>
@@ -11511,22 +12041,39 @@
               <a:t>  </a:t>
             </a:r>
             <a:r>
-              <a:rPr sz="1725" b="0">
-                <a:solidFill>
-                  <a:srgbClr val="152036"/>
-                </a:solidFill>
-                <a:latin typeface="Arial"/>
-                <a:ea typeface="Arial"/>
-                <a:cs typeface="Arial"/>
-              </a:rPr>
-              <a:t>Use of Low Power Equipment in the Frequency Band 865–868 MHz for Short Range Devices (Exemption from Licence) Rules, 2021. G.S.R. 853(E), 10 December 2021.</a:t>
-            </a:r>
-          </a:p>
-          <a:p>
-            <a:pPr algn="l">
+              <a:rPr kumimoji="0" lang="en-US" sz="1725" b="0" i="0" u="none" strike="noStrike" kern="1200" cap="none" spc="0" normalizeH="0" baseline="0" noProof="0" dirty="0">
+                <a:ln>
+                  <a:noFill/>
+                </a:ln>
+                <a:solidFill>
+                  <a:srgbClr val="152036"/>
+                </a:solidFill>
+                <a:effectLst/>
+                <a:uLnTx/>
+                <a:uFillTx/>
+                <a:latin typeface="Arial"/>
+                <a:ea typeface="Arial"/>
+                <a:cs typeface="Arial"/>
+              </a:rPr>
+              <a:t>A Method to Predict the Time of Slope Failure Caused by Rainfall Using the Inverse Number of Velocity of Surface Displacement. Landslides 22(2), 8–13. DOI: 10.3313/jls1964.22.2_8.</a:t>
+            </a:r>
+          </a:p>
+          <a:p>
+            <a:pPr marL="0" marR="0" lvl="0" indent="0" algn="l" defTabSz="914400" rtl="0" eaLnBrk="1" fontAlgn="auto" latinLnBrk="0" hangingPunct="1">
+              <a:lnSpc>
+                <a:spcPct val="100000"/>
+              </a:lnSpc>
+              <a:spcBef>
+                <a:spcPts val="0"/>
+              </a:spcBef>
               <a:spcAft>
                 <a:spcPts val="1600"/>
               </a:spcAft>
+              <a:buClrTx/>
+              <a:buSzTx/>
+              <a:buFontTx/>
+              <a:buNone/>
+              <a:tabLst/>
               <a:defRPr sz="1725">
                 <a:solidFill>
                   <a:srgbClr val="152036"/>
@@ -11537,22 +12084,146 @@
               </a:defRPr>
             </a:pPr>
             <a:r>
-              <a:rPr sz="1725" b="1">
-                <a:solidFill>
-                  <a:srgbClr val="152036"/>
-                </a:solidFill>
-                <a:latin typeface="Arial"/>
-                <a:ea typeface="Arial"/>
-                <a:cs typeface="Arial"/>
-                <a:hlinkClick r:id="rId10"/>
+              <a:rPr kumimoji="0" lang="en-US" sz="1725" b="1" i="0" u="none" strike="noStrike" kern="1200" cap="none" spc="0" normalizeH="0" baseline="0" noProof="0" dirty="0">
+                <a:ln>
+                  <a:noFill/>
+                </a:ln>
+                <a:solidFill>
+                  <a:srgbClr val="152036"/>
+                </a:solidFill>
+                <a:effectLst/>
+                <a:uLnTx/>
+                <a:uFillTx/>
+                <a:latin typeface="Arial"/>
+                <a:ea typeface="Arial"/>
+                <a:cs typeface="Arial"/>
+                <a:hlinkClick r:id="rId11"/>
+              </a:rPr>
+              <a:t>[6] Department of Telecommunications / WPC (2021)</a:t>
+            </a:r>
+            <a:r>
+              <a:rPr kumimoji="0" lang="en-US" sz="1725" b="1" i="0" u="none" strike="noStrike" kern="1200" cap="none" spc="0" normalizeH="0" baseline="0" noProof="0" dirty="0">
+                <a:ln>
+                  <a:noFill/>
+                </a:ln>
+                <a:solidFill>
+                  <a:srgbClr val="152036"/>
+                </a:solidFill>
+                <a:effectLst/>
+                <a:uLnTx/>
+                <a:uFillTx/>
+                <a:latin typeface="Arial"/>
+                <a:ea typeface="Arial"/>
+                <a:cs typeface="Arial"/>
+              </a:rPr>
+              <a:t>  </a:t>
+            </a:r>
+            <a:r>
+              <a:rPr kumimoji="0" lang="en-US" sz="1725" b="0" i="0" u="none" strike="noStrike" kern="1200" cap="none" spc="0" normalizeH="0" baseline="0" noProof="0" dirty="0">
+                <a:ln>
+                  <a:noFill/>
+                </a:ln>
+                <a:solidFill>
+                  <a:srgbClr val="152036"/>
+                </a:solidFill>
+                <a:effectLst/>
+                <a:uLnTx/>
+                <a:uFillTx/>
+                <a:latin typeface="Arial"/>
+                <a:ea typeface="Arial"/>
+                <a:cs typeface="Arial"/>
+              </a:rPr>
+              <a:t>Use of Low Power Equipment in the Frequency Band 865–868 MHz for Short Range Devices (Exemption from </a:t>
+            </a:r>
+            <a:r>
+              <a:rPr kumimoji="0" lang="en-US" sz="1725" b="0" i="0" u="none" strike="noStrike" kern="1200" cap="none" spc="0" normalizeH="0" baseline="0" noProof="0" dirty="0" err="1">
+                <a:ln>
+                  <a:noFill/>
+                </a:ln>
+                <a:solidFill>
+                  <a:srgbClr val="152036"/>
+                </a:solidFill>
+                <a:effectLst/>
+                <a:uLnTx/>
+                <a:uFillTx/>
+                <a:latin typeface="Arial"/>
+                <a:ea typeface="Arial"/>
+                <a:cs typeface="Arial"/>
+              </a:rPr>
+              <a:t>Licence</a:t>
+            </a:r>
+            <a:r>
+              <a:rPr kumimoji="0" lang="en-US" sz="1725" b="0" i="0" u="none" strike="noStrike" kern="1200" cap="none" spc="0" normalizeH="0" baseline="0" noProof="0" dirty="0">
+                <a:ln>
+                  <a:noFill/>
+                </a:ln>
+                <a:solidFill>
+                  <a:srgbClr val="152036"/>
+                </a:solidFill>
+                <a:effectLst/>
+                <a:uLnTx/>
+                <a:uFillTx/>
+                <a:latin typeface="Arial"/>
+                <a:ea typeface="Arial"/>
+                <a:cs typeface="Arial"/>
+              </a:rPr>
+              <a:t>) Rules, 2021. G.S.R. 853(E), 10 December 2021.</a:t>
+            </a:r>
+          </a:p>
+          <a:p>
+            <a:pPr marL="0" marR="0" lvl="0" indent="0" algn="l" defTabSz="914400" rtl="0" eaLnBrk="1" fontAlgn="auto" latinLnBrk="0" hangingPunct="1">
+              <a:lnSpc>
+                <a:spcPct val="100000"/>
+              </a:lnSpc>
+              <a:spcBef>
+                <a:spcPts val="0"/>
+              </a:spcBef>
+              <a:spcAft>
+                <a:spcPts val="1600"/>
+              </a:spcAft>
+              <a:buClrTx/>
+              <a:buSzTx/>
+              <a:buFontTx/>
+              <a:buNone/>
+              <a:tabLst/>
+              <a:defRPr sz="1725">
+                <a:solidFill>
+                  <a:srgbClr val="152036"/>
+                </a:solidFill>
+                <a:latin typeface="Arial"/>
+                <a:ea typeface="Arial"/>
+                <a:cs typeface="Arial"/>
+              </a:defRPr>
+            </a:pPr>
+            <a:r>
+              <a:rPr kumimoji="0" lang="en-US" sz="1725" b="1" i="0" u="none" strike="noStrike" kern="1200" cap="none" spc="0" normalizeH="0" baseline="0" noProof="0" dirty="0">
+                <a:ln>
+                  <a:noFill/>
+                </a:ln>
+                <a:solidFill>
+                  <a:srgbClr val="152036"/>
+                </a:solidFill>
+                <a:effectLst/>
+                <a:uLnTx/>
+                <a:uFillTx/>
+                <a:latin typeface="Arial"/>
+                <a:ea typeface="Arial"/>
+                <a:cs typeface="Arial"/>
+                <a:hlinkClick r:id="rId12"/>
               </a:rPr>
               <a:t>[7] ISRO (2023)</a:t>
             </a:r>
             <a:r>
-              <a:rPr sz="1725" b="1">
-                <a:solidFill>
-                  <a:srgbClr val="152036"/>
-                </a:solidFill>
+              <a:rPr kumimoji="0" lang="en-US" sz="1725" b="1" i="0" u="none" strike="noStrike" kern="1200" cap="none" spc="0" normalizeH="0" baseline="0" noProof="0" dirty="0">
+                <a:ln>
+                  <a:noFill/>
+                </a:ln>
+                <a:solidFill>
+                  <a:srgbClr val="152036"/>
+                </a:solidFill>
+                <a:effectLst/>
+                <a:uLnTx/>
+                <a:uFillTx/>
                 <a:latin typeface="Arial"/>
                 <a:ea typeface="Arial"/>
                 <a:cs typeface="Arial"/>
@@ -11560,16 +12231,295 @@
               <a:t>  </a:t>
             </a:r>
             <a:r>
-              <a:rPr sz="1725" b="0">
-                <a:solidFill>
-                  <a:srgbClr val="152036"/>
-                </a:solidFill>
+              <a:rPr kumimoji="0" lang="en-US" sz="1725" b="0" i="0" u="none" strike="noStrike" kern="1200" cap="none" spc="0" normalizeH="0" baseline="0" noProof="0" dirty="0">
+                <a:ln>
+                  <a:noFill/>
+                </a:ln>
+                <a:solidFill>
+                  <a:srgbClr val="152036"/>
+                </a:solidFill>
+                <a:effectLst/>
+                <a:uLnTx/>
+                <a:uFillTx/>
                 <a:latin typeface="Arial"/>
                 <a:ea typeface="Arial"/>
                 <a:cs typeface="Arial"/>
               </a:rPr>
               <a:t>PSLV-C56 / DS-SAR Mission. Official mission description confirms all-weather, day-and-night SAR coverage.</a:t>
             </a:r>
+          </a:p>
+          <a:p>
+            <a:pPr marL="0" marR="0" lvl="0" indent="0" algn="l" defTabSz="914400" rtl="0" eaLnBrk="1" fontAlgn="auto" latinLnBrk="0" hangingPunct="1">
+              <a:lnSpc>
+                <a:spcPct val="100000"/>
+              </a:lnSpc>
+              <a:spcBef>
+                <a:spcPts val="0"/>
+              </a:spcBef>
+              <a:spcAft>
+                <a:spcPts val="0"/>
+              </a:spcAft>
+              <a:buClrTx/>
+              <a:buSzTx/>
+              <a:buFontTx/>
+              <a:buNone/>
+              <a:tabLst/>
+              <a:defRPr/>
+            </a:pPr>
+            <a:r>
+              <a:rPr kumimoji="0" lang="en-US" sz="1800" b="1" i="0" u="none" strike="noStrike" kern="1200" cap="none" spc="0" normalizeH="0" baseline="0" noProof="0" dirty="0">
+                <a:ln>
+                  <a:noFill/>
+                </a:ln>
+                <a:solidFill>
+                  <a:srgbClr val="244F81"/>
+                </a:solidFill>
+                <a:effectLst/>
+                <a:uLnTx/>
+                <a:uFillTx/>
+                <a:latin typeface="Arial" panose="020B0604020202020204" pitchFamily="34" charset="0"/>
+                <a:ea typeface="+mn-ea"/>
+                <a:cs typeface="Arial" panose="020B0604020202020204" pitchFamily="34" charset="0"/>
+              </a:rPr>
+              <a:t>PROJECT LINKS</a:t>
+            </a:r>
+          </a:p>
+          <a:p>
+            <a:pPr marL="0" marR="0" lvl="0" indent="0" algn="l" defTabSz="914400" rtl="0" eaLnBrk="1" fontAlgn="auto" latinLnBrk="0" hangingPunct="1">
+              <a:lnSpc>
+                <a:spcPct val="100000"/>
+              </a:lnSpc>
+              <a:spcBef>
+                <a:spcPts val="0"/>
+              </a:spcBef>
+              <a:spcAft>
+                <a:spcPts val="0"/>
+              </a:spcAft>
+              <a:buClrTx/>
+              <a:buSzTx/>
+              <a:buFontTx/>
+              <a:buNone/>
+              <a:tabLst/>
+              <a:defRPr/>
+            </a:pPr>
+            <a:endParaRPr kumimoji="0" lang="en-US" sz="1800" b="1" i="0" u="none" strike="noStrike" kern="1200" cap="none" spc="0" normalizeH="0" baseline="0" noProof="0" dirty="0">
+              <a:ln>
+                <a:noFill/>
+              </a:ln>
+              <a:solidFill>
+                <a:srgbClr val="244F81"/>
+              </a:solidFill>
+              <a:effectLst/>
+              <a:uLnTx/>
+              <a:uFillTx/>
+              <a:latin typeface="Arial" panose="020B0604020202020204" pitchFamily="34" charset="0"/>
+              <a:ea typeface="+mn-ea"/>
+              <a:cs typeface="Arial" panose="020B0604020202020204" pitchFamily="34" charset="0"/>
+            </a:endParaRPr>
+          </a:p>
+          <a:p>
+            <a:pPr marL="0" marR="0" lvl="0" indent="0" algn="l" defTabSz="914400" rtl="0" eaLnBrk="1" fontAlgn="auto" latinLnBrk="0" hangingPunct="1">
+              <a:lnSpc>
+                <a:spcPct val="100000"/>
+              </a:lnSpc>
+              <a:spcBef>
+                <a:spcPts val="0"/>
+              </a:spcBef>
+              <a:spcAft>
+                <a:spcPts val="0"/>
+              </a:spcAft>
+              <a:buClrTx/>
+              <a:buSzTx/>
+              <a:buFontTx/>
+              <a:buNone/>
+              <a:tabLst/>
+              <a:defRPr/>
+            </a:pPr>
+            <a:r>
+              <a:rPr kumimoji="0" lang="en-US" sz="1800" b="0" i="0" u="none" strike="noStrike" kern="1200" cap="none" spc="0" normalizeH="0" baseline="0" noProof="0" dirty="0">
+                <a:ln>
+                  <a:noFill/>
+                </a:ln>
+                <a:solidFill>
+                  <a:srgbClr val="193247"/>
+                </a:solidFill>
+                <a:effectLst/>
+                <a:uLnTx/>
+                <a:uFillTx/>
+                <a:latin typeface="Arial" panose="020B0604020202020204" pitchFamily="34" charset="0"/>
+                <a:ea typeface="+mn-ea"/>
+                <a:cs typeface="Arial" panose="020B0604020202020204" pitchFamily="34" charset="0"/>
+              </a:rPr>
+              <a:t>GitHub: </a:t>
+            </a:r>
+            <a:r>
+              <a:rPr kumimoji="0" lang="en-US" sz="1800" b="0" i="0" u="none" strike="noStrike" kern="1200" cap="none" spc="0" normalizeH="0" baseline="0" noProof="0" dirty="0">
+                <a:ln>
+                  <a:noFill/>
+                </a:ln>
+                <a:solidFill>
+                  <a:srgbClr val="193247"/>
+                </a:solidFill>
+                <a:effectLst/>
+                <a:uLnTx/>
+                <a:uFillTx/>
+                <a:latin typeface="Arial" panose="020B0604020202020204" pitchFamily="34" charset="0"/>
+                <a:ea typeface="+mn-ea"/>
+                <a:cs typeface="Arial" panose="020B0604020202020204" pitchFamily="34" charset="0"/>
+                <a:hlinkClick r:id="rId13"/>
+              </a:rPr>
+              <a:t>https://github.com/sharequesyed/SubsiGuardAI</a:t>
+            </a:r>
+            <a:endParaRPr kumimoji="0" lang="en-US" sz="1800" b="0" i="0" u="none" strike="noStrike" kern="1200" cap="none" spc="0" normalizeH="0" baseline="0" noProof="0" dirty="0">
+              <a:ln>
+                <a:noFill/>
+              </a:ln>
+              <a:solidFill>
+                <a:srgbClr val="193247"/>
+              </a:solidFill>
+              <a:effectLst/>
+              <a:uLnTx/>
+              <a:uFillTx/>
+              <a:latin typeface="Arial" panose="020B0604020202020204" pitchFamily="34" charset="0"/>
+              <a:ea typeface="+mn-ea"/>
+              <a:cs typeface="Arial" panose="020B0604020202020204" pitchFamily="34" charset="0"/>
+            </a:endParaRPr>
+          </a:p>
+          <a:p>
+            <a:pPr marL="0" marR="0" lvl="0" indent="0" algn="l" defTabSz="914400" rtl="0" eaLnBrk="1" fontAlgn="auto" latinLnBrk="0" hangingPunct="1">
+              <a:lnSpc>
+                <a:spcPct val="100000"/>
+              </a:lnSpc>
+              <a:spcBef>
+                <a:spcPts val="0"/>
+              </a:spcBef>
+              <a:spcAft>
+                <a:spcPts val="0"/>
+              </a:spcAft>
+              <a:buClrTx/>
+              <a:buSzTx/>
+              <a:buFontTx/>
+              <a:buNone/>
+              <a:tabLst/>
+              <a:defRPr/>
+            </a:pPr>
+            <a:endParaRPr kumimoji="0" lang="en-US" sz="1800" b="0" i="0" u="none" strike="noStrike" kern="1200" cap="none" spc="0" normalizeH="0" baseline="0" noProof="0" dirty="0">
+              <a:ln>
+                <a:noFill/>
+              </a:ln>
+              <a:solidFill>
+                <a:srgbClr val="193247"/>
+              </a:solidFill>
+              <a:effectLst/>
+              <a:uLnTx/>
+              <a:uFillTx/>
+              <a:latin typeface="Arial" panose="020B0604020202020204" pitchFamily="34" charset="0"/>
+              <a:ea typeface="+mn-ea"/>
+              <a:cs typeface="Arial" panose="020B0604020202020204" pitchFamily="34" charset="0"/>
+            </a:endParaRPr>
+          </a:p>
+          <a:p>
+            <a:pPr>
+              <a:defRPr/>
+            </a:pPr>
+            <a:r>
+              <a:rPr lang="en-US" dirty="0">
+                <a:solidFill>
+                  <a:srgbClr val="193247"/>
+                </a:solidFill>
+                <a:latin typeface="Arial" panose="020B0604020202020204" pitchFamily="34" charset="0"/>
+                <a:cs typeface="Arial" panose="020B0604020202020204" pitchFamily="34" charset="0"/>
+              </a:rPr>
+              <a:t>Dashboard: https://subsi-guard-ai.vercel.app/</a:t>
+            </a:r>
+            <a:endParaRPr kumimoji="0" lang="en-US" sz="1800" b="1" i="0" u="none" strike="noStrike" kern="1200" cap="none" spc="0" normalizeH="0" baseline="0" noProof="0" dirty="0">
+              <a:ln>
+                <a:noFill/>
+              </a:ln>
+              <a:solidFill>
+                <a:srgbClr val="244F81"/>
+              </a:solidFill>
+              <a:effectLst/>
+              <a:uLnTx/>
+              <a:uFillTx/>
+              <a:latin typeface="Arial" panose="020B0604020202020204" pitchFamily="34" charset="0"/>
+              <a:ea typeface="+mn-ea"/>
+              <a:cs typeface="Arial" panose="020B0604020202020204" pitchFamily="34" charset="0"/>
+            </a:endParaRPr>
+          </a:p>
+          <a:p>
+            <a:pPr marL="0" marR="0" lvl="0" indent="0" algn="l" defTabSz="914400" rtl="0" eaLnBrk="1" fontAlgn="auto" latinLnBrk="0" hangingPunct="1">
+              <a:lnSpc>
+                <a:spcPct val="100000"/>
+              </a:lnSpc>
+              <a:spcBef>
+                <a:spcPts val="0"/>
+              </a:spcBef>
+              <a:spcAft>
+                <a:spcPts val="1600"/>
+              </a:spcAft>
+              <a:buClrTx/>
+              <a:buSzTx/>
+              <a:buFontTx/>
+              <a:buNone/>
+              <a:tabLst/>
+              <a:defRPr sz="1725">
+                <a:solidFill>
+                  <a:srgbClr val="152036"/>
+                </a:solidFill>
+                <a:latin typeface="Arial"/>
+                <a:ea typeface="Arial"/>
+                <a:cs typeface="Arial"/>
+              </a:defRPr>
+            </a:pPr>
+            <a:endParaRPr lang="en-US" sz="1725" dirty="0">
+              <a:solidFill>
+                <a:srgbClr val="152036"/>
+              </a:solidFill>
+              <a:latin typeface="Arial"/>
+              <a:ea typeface="Arial"/>
+              <a:cs typeface="Arial"/>
+            </a:endParaRPr>
+          </a:p>
+          <a:p>
+            <a:pPr marL="0" marR="0" lvl="0" indent="0" algn="l" defTabSz="914400" rtl="0" eaLnBrk="1" fontAlgn="auto" latinLnBrk="0" hangingPunct="1">
+              <a:lnSpc>
+                <a:spcPct val="100000"/>
+              </a:lnSpc>
+              <a:spcBef>
+                <a:spcPts val="0"/>
+              </a:spcBef>
+              <a:spcAft>
+                <a:spcPts val="1600"/>
+              </a:spcAft>
+              <a:buClrTx/>
+              <a:buSzTx/>
+              <a:buFontTx/>
+              <a:buNone/>
+              <a:tabLst/>
+              <a:defRPr sz="1725">
+                <a:solidFill>
+                  <a:srgbClr val="152036"/>
+                </a:solidFill>
+                <a:latin typeface="Arial"/>
+                <a:ea typeface="Arial"/>
+                <a:cs typeface="Arial"/>
+              </a:defRPr>
+            </a:pPr>
+            <a:endParaRPr kumimoji="0" lang="en-US" sz="1725" b="0" i="0" u="none" strike="noStrike" kern="1200" cap="none" spc="0" normalizeH="0" baseline="0" noProof="0" dirty="0">
+              <a:ln>
+                <a:noFill/>
+              </a:ln>
+              <a:solidFill>
+                <a:srgbClr val="152036"/>
+              </a:solidFill>
+              <a:effectLst/>
+              <a:uLnTx/>
+              <a:uFillTx/>
+              <a:latin typeface="Arial"/>
+              <a:ea typeface="Arial"/>
+              <a:cs typeface="Arial"/>
+            </a:endParaRPr>
           </a:p>
         </p:txBody>
       </p:sp>

</xml_diff>